<commit_message>
Kit 7: universal lab-exemplar retrofit (owner directive)
Ms. Rivera follows one week audit through all four lab steps: starred
repeaters, worst star to template #1 (the sub plan from slide 9), star
two to template #2 posted to the staff doc, the needs-my-kids column to
her protected list. Large exemplar cards on slides 19-22, chips and
script rivera-lines aligned, teaching content and timings unchanged.
Rebuilt and visually verified per KIT_STANDARD.

Co-Authored-By: Claude Fable 5 <noreply@anthropic.com>
Claude-Session: https://claude.ai/code/session_019agQ42s1igQaB2X7GGat9R
</commit_message>
<xml_diff>
--- a/kits/kit07/Kit07_PresentationDeck.pptx
+++ b/kits/kit07/Kit07_PresentationDeck.pptx
@@ -1323,7 +1323,7 @@
           <a:p>
             <a:r>
               <a:rPr lang="en-US" dirty="0"/>
-              <a:t>Dark slide. Devices out, pairs formed inside two minutes, announce the tool.</a:t>
+              <a:t>Dark slide. Devices out, pairs formed inside two minutes, announce the tool. Say: Ms. Rivera works ONE artifact through all four steps, her own week audit; her exemplar appears large on every step slide, so anyone lost can copy her structure.</a:t>
             </a:r>
             <a:endParaRPr lang="en-US" dirty="0"/>
           </a:p>
@@ -1411,7 +1411,7 @@
           <a:p>
             <a:r>
               <a:rPr lang="en-US" dirty="0"/>
-              <a:t>5 minutes. The handout has the quadrant grid. The common miss is the fifteen-minute repeaters; they're where the hours hide.</a:t>
+              <a:t>5 minutes. The handout has the quadrant grid. The common miss is the fifteen-minute repeaters; they're where the hours hide. Ms. Rivera's finished audit is on screen large: one sheet she carries through all four steps. Stars are her delegable repeaters; the unstarred lines stay hers. Anyone lost copies her format.</a:t>
             </a:r>
             <a:endParaRPr lang="en-US" dirty="0"/>
           </a:p>
@@ -1587,7 +1587,7 @@
           <a:p>
             <a:r>
               <a:rPr lang="en-US" dirty="0"/>
-              <a:t>6 minutes. Push for testing on a REAL instance, not admiring the template. Circulate.</a:t>
+              <a:t>6 minutes. Push for testing on a REAL instance, not admiring the template. Circulate. Ms. Rivera's card shows the same audit narrowing: her worst star, the sub plan, is now template #1, built to slide 9's shape and tested twice.</a:t>
             </a:r>
             <a:endParaRPr lang="en-US" dirty="0"/>
           </a:p>
@@ -1675,7 +1675,7 @@
           <a:p>
             <a:r>
               <a:rPr lang="en-US" dirty="0"/>
-              <a:t>6 minutes. 45-min cut: skip #2 (it moves to the First 48 Hours sheet) and post #1 now.</a:t>
+              <a:t>6 minutes. 45-min cut: skip #2 (it moves to the First 48 Hours sheet) and post #1 now. Ms. Rivera's card: star #2 off the same audit, exit tickets, templated the same way; both of her templates go to the staff doc.</a:t>
             </a:r>
             <a:endParaRPr lang="en-US" dirty="0"/>
           </a:p>
@@ -1763,7 +1763,7 @@
           <a:p>
             <a:r>
               <a:rPr lang="en-US" dirty="0"/>
-              <a:t>3 minutes, quiet, alone, in ink. This is the step people remember; give it silence.</a:t>
+              <a:t>3 minutes, quiet, alone, in ink. This is the step people remember; give it silence. Ms. Rivera's card closes the loop: the lines she never starred in step 1 are exactly what her protected list protects.</a:t>
             </a:r>
             <a:endParaRPr lang="en-US" dirty="0"/>
           </a:p>
@@ -9496,7 +9496,7 @@
                 <a:ea typeface="Inter" pitchFamily="34" charset="-122"/>
                 <a:cs typeface="Inter" pitchFamily="34" charset="-120"/>
               </a:rPr>
-              <a:t>Her lab: audit the real week, pick two, build both.</a:t>
+              <a:t>Her lab artifact: her own week audit, one sheet worked through all four steps.</a:t>
             </a:r>
             <a:endParaRPr lang="en-US" sz="1000" dirty="0"/>
           </a:p>
@@ -10277,7 +10277,7 @@
                 <a:ea typeface="Inter" pitchFamily="34" charset="-122"/>
                 <a:cs typeface="Inter" pitchFamily="34" charset="-120"/>
               </a:rPr>
-              <a:t>On her screen: the audit: every recurring task, sorted in ten minutes.</a:t>
+              <a:t>Her week audit, step 1: every repeater listed and starred; worst star, the sub plan.</a:t>
             </a:r>
             <a:endParaRPr lang="en-US" sz="1000" dirty="0"/>
           </a:p>
@@ -10331,7 +10331,7 @@
         <p:spPr>
           <a:xfrm>
             <a:off x="548640" y="384048"/>
-            <a:ext cx="11091672" cy="777240"/>
+            <a:ext cx="7955280" cy="777240"/>
           </a:xfrm>
           <a:prstGeom prst="rect">
             <a:avLst/>
@@ -10369,8 +10369,8 @@
         </p:nvSpPr>
         <p:spPr>
           <a:xfrm>
-            <a:off x="640080" y="1371600"/>
-            <a:ext cx="10908792" cy="4297680"/>
+            <a:off x="640080" y="1554480"/>
+            <a:ext cx="5394960" cy="4023360"/>
           </a:xfrm>
           <a:prstGeom prst="rect">
             <a:avLst/>
@@ -10390,7 +10390,7 @@
               <a:buChar char="•"/>
             </a:pPr>
             <a:r>
-              <a:rPr lang="en-US" sz="2100" dirty="0">
+              <a:rPr lang="en-US" sz="1800" dirty="0">
                 <a:solidFill>
                   <a:srgbClr val="1B1F24"/>
                 </a:solidFill>
@@ -10400,7 +10400,7 @@
               </a:rPr>
               <a:t>List every task from last week that you'll do again, small ones included</a:t>
             </a:r>
-            <a:endParaRPr lang="en-US" sz="2100" dirty="0"/>
+            <a:endParaRPr lang="en-US" sz="1800" dirty="0"/>
           </a:p>
           <a:p>
             <a:pPr marL="342900" indent="-342900">
@@ -10411,7 +10411,7 @@
               <a:buChar char="•"/>
             </a:pPr>
             <a:r>
-              <a:rPr lang="en-US" sz="2100" dirty="0">
+              <a:rPr lang="en-US" sz="1800" dirty="0">
                 <a:solidFill>
                   <a:srgbClr val="1B1F24"/>
                 </a:solidFill>
@@ -10421,7 +10421,7 @@
               </a:rPr>
               <a:t>Run the two questions on each: needs my kids? repeats?</a:t>
             </a:r>
-            <a:endParaRPr lang="en-US" sz="2100" dirty="0"/>
+            <a:endParaRPr lang="en-US" sz="1800" dirty="0"/>
           </a:p>
           <a:p>
             <a:pPr marL="342900" indent="-342900">
@@ -10432,7 +10432,7 @@
               <a:buChar char="•"/>
             </a:pPr>
             <a:r>
-              <a:rPr lang="en-US" sz="2100" dirty="0">
+              <a:rPr lang="en-US" sz="1800" dirty="0">
                 <a:solidFill>
                   <a:srgbClr val="1B1F24"/>
                 </a:solidFill>
@@ -10442,7 +10442,7 @@
               </a:rPr>
               <a:t>Star everything that repeats and doesn't need your kids</a:t>
             </a:r>
-            <a:endParaRPr lang="en-US" sz="2100" dirty="0"/>
+            <a:endParaRPr lang="en-US" sz="1800" dirty="0"/>
           </a:p>
           <a:p>
             <a:pPr marL="342900" indent="-342900">
@@ -10453,7 +10453,7 @@
               <a:buChar char="•"/>
             </a:pPr>
             <a:r>
-              <a:rPr lang="en-US" sz="2100" b="1" dirty="0">
+              <a:rPr lang="en-US" sz="1800" b="1" dirty="0">
                 <a:solidFill>
                   <a:srgbClr val="1B1F24"/>
                 </a:solidFill>
@@ -10463,7 +10463,223 @@
               </a:rPr>
               <a:t>Most people find six to ten stars. Each is a candidate.</a:t>
             </a:r>
-            <a:endParaRPr lang="en-US" sz="2100" dirty="0"/>
+            <a:endParaRPr lang="en-US" sz="1800" dirty="0"/>
+          </a:p>
+        </p:txBody>
+      </p:sp>
+      <p:sp>
+        <p:nvSpPr>
+          <p:cNvPr id="15" name="Shape 12"/>
+          <p:cNvSpPr/>
+          <p:nvPr/>
+        </p:nvSpPr>
+        <p:spPr>
+          <a:xfrm>
+            <a:off x="6263640" y="1554480"/>
+            <a:ext cx="5394960" cy="4023360"/>
+          </a:xfrm>
+          <a:prstGeom prst="roundRect">
+            <a:avLst>
+              <a:gd name="adj" fmla="val 2045"/>
+            </a:avLst>
+          </a:prstGeom>
+          <a:solidFill>
+            <a:srgbClr val="EAF5F3"/>
+          </a:solidFill>
+          <a:ln w="12700">
+            <a:solidFill>
+              <a:srgbClr val="EAF5F3"/>
+            </a:solidFill>
+            <a:prstDash val="solid"/>
+          </a:ln>
+        </p:spPr>
+      </p:sp>
+      <p:sp>
+        <p:nvSpPr>
+          <p:cNvPr id="16" name="Text 13"/>
+          <p:cNvSpPr/>
+          <p:nvPr/>
+        </p:nvSpPr>
+        <p:spPr>
+          <a:xfrm>
+            <a:off x="6537960" y="1737360"/>
+            <a:ext cx="4937760" cy="292608"/>
+          </a:xfrm>
+          <a:prstGeom prst="rect">
+            <a:avLst/>
+          </a:prstGeom>
+          <a:noFill/>
+          <a:ln/>
+        </p:spPr>
+        <p:txBody>
+          <a:bodyPr wrap="square" lIns="0" tIns="0" rIns="0" bIns="0" rtlCol="0" anchor="ctr"/>
+          <a:lstStyle/>
+          <a:p>
+            <a:pPr indent="0" marL="0">
+              <a:buNone/>
+            </a:pPr>
+            <a:r>
+              <a:rPr lang="en-US" sz="1250" b="1" spc="150" kern="0" dirty="0">
+                <a:solidFill>
+                  <a:srgbClr val="2A9D8F"/>
+                </a:solidFill>
+                <a:latin typeface="Inter" pitchFamily="34" charset="0"/>
+                <a:ea typeface="Inter" pitchFamily="34" charset="-122"/>
+                <a:cs typeface="Inter" pitchFamily="34" charset="-120"/>
+              </a:rPr>
+              <a:t>MS. RIVERA'S WEEK AUDIT · STEP 1</a:t>
+            </a:r>
+            <a:endParaRPr lang="en-US" sz="1250" dirty="0"/>
+          </a:p>
+        </p:txBody>
+      </p:sp>
+      <p:sp>
+        <p:nvSpPr>
+          <p:cNvPr id="17" name="Text 14"/>
+          <p:cNvSpPr/>
+          <p:nvPr/>
+        </p:nvSpPr>
+        <p:spPr>
+          <a:xfrm>
+            <a:off x="6537960" y="2148840"/>
+            <a:ext cx="4892040" cy="3291840"/>
+          </a:xfrm>
+          <a:prstGeom prst="rect">
+            <a:avLst/>
+          </a:prstGeom>
+          <a:noFill/>
+          <a:ln/>
+        </p:spPr>
+        <p:txBody>
+          <a:bodyPr wrap="square" lIns="0" tIns="0" rIns="0" bIns="0" rtlCol="0" anchor="t"/>
+          <a:lstStyle/>
+          <a:p>
+            <a:pPr indent="0" marL="0">
+              <a:lnSpc>
+                <a:spcPct val="120000"/>
+              </a:lnSpc>
+              <a:buNone/>
+            </a:pPr>
+            <a:r>
+              <a:rPr lang="en-US" sz="1900" b="1" dirty="0">
+                <a:solidFill>
+                  <a:srgbClr val="13293D"/>
+                </a:solidFill>
+                <a:latin typeface="Inter" pitchFamily="34" charset="0"/>
+                <a:ea typeface="Inter" pitchFamily="34" charset="-122"/>
+                <a:cs typeface="Inter" pitchFamily="34" charset="-120"/>
+              </a:rPr>
+              <a:t>★ Sub plans, every absence
+</a:t>
+            </a:r>
+            <a:pPr indent="0" marL="0">
+              <a:lnSpc>
+                <a:spcPct val="120000"/>
+              </a:lnSpc>
+              <a:buNone/>
+            </a:pPr>
+            <a:r>
+              <a:rPr lang="en-US" sz="1900" b="1" dirty="0">
+                <a:solidFill>
+                  <a:srgbClr val="13293D"/>
+                </a:solidFill>
+                <a:latin typeface="Inter" pitchFamily="34" charset="0"/>
+                <a:ea typeface="Inter" pitchFamily="34" charset="-122"/>
+                <a:cs typeface="Inter" pitchFamily="34" charset="-120"/>
+              </a:rPr>
+              <a:t>★ Exit tickets, weekly
+</a:t>
+            </a:r>
+            <a:pPr indent="0" marL="0">
+              <a:lnSpc>
+                <a:spcPct val="120000"/>
+              </a:lnSpc>
+              <a:buNone/>
+            </a:pPr>
+            <a:r>
+              <a:rPr lang="en-US" sz="1900" b="1" dirty="0">
+                <a:solidFill>
+                  <a:srgbClr val="13293D"/>
+                </a:solidFill>
+                <a:latin typeface="Inter" pitchFamily="34" charset="0"/>
+                <a:ea typeface="Inter" pitchFamily="34" charset="-122"/>
+                <a:cs typeface="Inter" pitchFamily="34" charset="-120"/>
+              </a:rPr>
+              <a:t>★ Newsletter shell
+</a:t>
+            </a:r>
+            <a:pPr indent="0" marL="0">
+              <a:lnSpc>
+                <a:spcPct val="120000"/>
+              </a:lnSpc>
+              <a:buNone/>
+            </a:pPr>
+            <a:r>
+              <a:rPr lang="en-US" sz="1900" b="1" dirty="0">
+                <a:solidFill>
+                  <a:srgbClr val="13293D"/>
+                </a:solidFill>
+                <a:latin typeface="Inter" pitchFamily="34" charset="0"/>
+                <a:ea typeface="Inter" pitchFamily="34" charset="-122"/>
+                <a:cs typeface="Inter" pitchFamily="34" charset="-120"/>
+              </a:rPr>
+              <a:t>★ Materials lists
+</a:t>
+            </a:r>
+            <a:pPr indent="0" marL="0">
+              <a:lnSpc>
+                <a:spcPct val="120000"/>
+              </a:lnSpc>
+              <a:buNone/>
+            </a:pPr>
+            <a:r>
+              <a:rPr lang="en-US" sz="1900" dirty="0">
+                <a:solidFill>
+                  <a:srgbClr val="1B1F24"/>
+                </a:solidFill>
+                <a:latin typeface="Inter" pitchFamily="34" charset="0"/>
+                <a:ea typeface="Inter" pitchFamily="34" charset="-122"/>
+                <a:cs typeface="Inter" pitchFamily="34" charset="-120"/>
+              </a:rPr>
+              <a:t>Reading groups: hers
+</a:t>
+            </a:r>
+            <a:pPr indent="0" marL="0">
+              <a:lnSpc>
+                <a:spcPct val="120000"/>
+              </a:lnSpc>
+              <a:buNone/>
+            </a:pPr>
+            <a:r>
+              <a:rPr lang="en-US" sz="1900" dirty="0">
+                <a:solidFill>
+                  <a:srgbClr val="1B1F24"/>
+                </a:solidFill>
+                <a:latin typeface="Inter" pitchFamily="34" charset="0"/>
+                <a:ea typeface="Inter" pitchFamily="34" charset="-122"/>
+                <a:cs typeface="Inter" pitchFamily="34" charset="-120"/>
+              </a:rPr>
+              <a:t>Feedback chats: hers
+</a:t>
+            </a:r>
+            <a:pPr indent="0" marL="0">
+              <a:lnSpc>
+                <a:spcPct val="120000"/>
+              </a:lnSpc>
+              <a:buNone/>
+            </a:pPr>
+            <a:r>
+              <a:rPr lang="en-US" sz="1900" i="1" dirty="0">
+                <a:solidFill>
+                  <a:srgbClr val="5B6B7A"/>
+                </a:solidFill>
+                <a:latin typeface="Inter" pitchFamily="34" charset="0"/>
+                <a:ea typeface="Inter" pitchFamily="34" charset="-122"/>
+                <a:cs typeface="Inter" pitchFamily="34" charset="-120"/>
+              </a:rPr>
+              <a:t>Worst star: the sub plan.</a:t>
+            </a:r>
+            <a:endParaRPr lang="en-US" sz="1900" dirty="0"/>
           </a:p>
         </p:txBody>
       </p:sp>
@@ -11576,7 +11792,7 @@
                 <a:ea typeface="Inter" pitchFamily="34" charset="-122"/>
                 <a:cs typeface="Inter" pitchFamily="34" charset="-120"/>
               </a:rPr>
-              <a:t>Her template #1: the sub plan, built and tested on a real instance.</a:t>
+              <a:t>Her week audit, step 2: the worst star, the sub plan, is now template #1, tested twice.</a:t>
             </a:r>
             <a:endParaRPr lang="en-US" sz="1000" dirty="0"/>
           </a:p>
@@ -11630,7 +11846,7 @@
         <p:spPr>
           <a:xfrm>
             <a:off x="548640" y="384048"/>
-            <a:ext cx="11091672" cy="777240"/>
+            <a:ext cx="7955280" cy="777240"/>
           </a:xfrm>
           <a:prstGeom prst="rect">
             <a:avLst/>
@@ -11668,8 +11884,8 @@
         </p:nvSpPr>
         <p:spPr>
           <a:xfrm>
-            <a:off x="640080" y="1371600"/>
-            <a:ext cx="10908792" cy="4297680"/>
+            <a:off x="640080" y="1554480"/>
+            <a:ext cx="5394960" cy="4023360"/>
           </a:xfrm>
           <a:prstGeom prst="rect">
             <a:avLst/>
@@ -11689,7 +11905,7 @@
               <a:buChar char="•"/>
             </a:pPr>
             <a:r>
-              <a:rPr lang="en-US" sz="2100" dirty="0">
+              <a:rPr lang="en-US" sz="1700" dirty="0">
                 <a:solidFill>
                   <a:srgbClr val="1B1F24"/>
                 </a:solidFill>
@@ -11699,7 +11915,7 @@
               </a:rPr>
               <a:t>Take your worst starred task: the one that costs the most evenings</a:t>
             </a:r>
-            <a:endParaRPr lang="en-US" sz="2100" dirty="0"/>
+            <a:endParaRPr lang="en-US" sz="1700" dirty="0"/>
           </a:p>
           <a:p>
             <a:pPr marL="342900" indent="-342900">
@@ -11710,7 +11926,7 @@
               <a:buChar char="•"/>
             </a:pPr>
             <a:r>
-              <a:rPr lang="en-US" sz="2100" dirty="0">
+              <a:rPr lang="en-US" sz="1700" dirty="0">
                 <a:solidFill>
                   <a:srgbClr val="1B1F24"/>
                 </a:solidFill>
@@ -11720,7 +11936,7 @@
               </a:rPr>
               <a:t>The recipe: write it once (four parts) → bracket the changes → test on a second instance</a:t>
             </a:r>
-            <a:endParaRPr lang="en-US" sz="2100" dirty="0"/>
+            <a:endParaRPr lang="en-US" sz="1700" dirty="0"/>
           </a:p>
           <a:p>
             <a:pPr marL="342900" indent="-342900">
@@ -11731,7 +11947,7 @@
               <a:buChar char="•"/>
             </a:pPr>
             <a:r>
-              <a:rPr lang="en-US" sz="2100" dirty="0">
+              <a:rPr lang="en-US" sz="1700" dirty="0">
                 <a:solidFill>
                   <a:srgbClr val="1B1F24"/>
                 </a:solidFill>
@@ -11739,9 +11955,9 @@
                 <a:ea typeface="Inter" pitchFamily="34" charset="-122"/>
                 <a:cs typeface="Inter" pitchFamily="34" charset="-120"/>
               </a:rPr>
-              <a:t>Mimic the sub-plan shape on Ms. Rivera's screen from slide 9</a:t>
-            </a:r>
-            <a:endParaRPr lang="en-US" sz="2100" dirty="0"/>
+              <a:t>Mimic Ms. Rivera's card: the sub-plan shape from slide 9</a:t>
+            </a:r>
+            <a:endParaRPr lang="en-US" sz="1700" dirty="0"/>
           </a:p>
           <a:p>
             <a:pPr marL="342900" indent="-342900">
@@ -11752,7 +11968,7 @@
               <a:buChar char="•"/>
             </a:pPr>
             <a:r>
-              <a:rPr lang="en-US" sz="2100" b="1" dirty="0">
+              <a:rPr lang="en-US" sz="1700" b="1" dirty="0">
                 <a:solidFill>
                   <a:srgbClr val="1B1F24"/>
                 </a:solidFill>
@@ -11762,7 +11978,151 @@
               </a:rPr>
               <a:t>When it works twice, it's real. Save it.</a:t>
             </a:r>
-            <a:endParaRPr lang="en-US" sz="2100" dirty="0"/>
+            <a:endParaRPr lang="en-US" sz="1700" dirty="0"/>
+          </a:p>
+        </p:txBody>
+      </p:sp>
+      <p:sp>
+        <p:nvSpPr>
+          <p:cNvPr id="15" name="Shape 12"/>
+          <p:cNvSpPr/>
+          <p:nvPr/>
+        </p:nvSpPr>
+        <p:spPr>
+          <a:xfrm>
+            <a:off x="6263640" y="1554480"/>
+            <a:ext cx="5394960" cy="4023360"/>
+          </a:xfrm>
+          <a:prstGeom prst="roundRect">
+            <a:avLst>
+              <a:gd name="adj" fmla="val 2045"/>
+            </a:avLst>
+          </a:prstGeom>
+          <a:solidFill>
+            <a:srgbClr val="EAF5F3"/>
+          </a:solidFill>
+          <a:ln w="12700">
+            <a:solidFill>
+              <a:srgbClr val="EAF5F3"/>
+            </a:solidFill>
+            <a:prstDash val="solid"/>
+          </a:ln>
+        </p:spPr>
+      </p:sp>
+      <p:sp>
+        <p:nvSpPr>
+          <p:cNvPr id="16" name="Text 13"/>
+          <p:cNvSpPr/>
+          <p:nvPr/>
+        </p:nvSpPr>
+        <p:spPr>
+          <a:xfrm>
+            <a:off x="6537960" y="1737360"/>
+            <a:ext cx="4937760" cy="292608"/>
+          </a:xfrm>
+          <a:prstGeom prst="rect">
+            <a:avLst/>
+          </a:prstGeom>
+          <a:noFill/>
+          <a:ln/>
+        </p:spPr>
+        <p:txBody>
+          <a:bodyPr wrap="square" lIns="0" tIns="0" rIns="0" bIns="0" rtlCol="0" anchor="ctr"/>
+          <a:lstStyle/>
+          <a:p>
+            <a:pPr indent="0" marL="0">
+              <a:buNone/>
+            </a:pPr>
+            <a:r>
+              <a:rPr lang="en-US" sz="1250" b="1" spc="150" kern="0" dirty="0">
+                <a:solidFill>
+                  <a:srgbClr val="2A9D8F"/>
+                </a:solidFill>
+                <a:latin typeface="Inter" pitchFamily="34" charset="0"/>
+                <a:ea typeface="Inter" pitchFamily="34" charset="-122"/>
+                <a:cs typeface="Inter" pitchFamily="34" charset="-120"/>
+              </a:rPr>
+              <a:t>MS. RIVERA'S WEEK AUDIT · STEP 2</a:t>
+            </a:r>
+            <a:endParaRPr lang="en-US" sz="1250" dirty="0"/>
+          </a:p>
+        </p:txBody>
+      </p:sp>
+      <p:sp>
+        <p:nvSpPr>
+          <p:cNvPr id="17" name="Text 14"/>
+          <p:cNvSpPr/>
+          <p:nvPr/>
+        </p:nvSpPr>
+        <p:spPr>
+          <a:xfrm>
+            <a:off x="6537960" y="2148840"/>
+            <a:ext cx="4892040" cy="3291840"/>
+          </a:xfrm>
+          <a:prstGeom prst="rect">
+            <a:avLst/>
+          </a:prstGeom>
+          <a:noFill/>
+          <a:ln/>
+        </p:spPr>
+        <p:txBody>
+          <a:bodyPr wrap="square" lIns="0" tIns="0" rIns="0" bIns="0" rtlCol="0" anchor="t"/>
+          <a:lstStyle/>
+          <a:p>
+            <a:pPr indent="0" marL="0">
+              <a:lnSpc>
+                <a:spcPct val="120000"/>
+              </a:lnSpc>
+              <a:buNone/>
+            </a:pPr>
+            <a:r>
+              <a:rPr lang="en-US" sz="1900" b="1" dirty="0">
+                <a:solidFill>
+                  <a:srgbClr val="13293D"/>
+                </a:solidFill>
+                <a:latin typeface="Inter" pitchFamily="34" charset="0"/>
+                <a:ea typeface="Inter" pitchFamily="34" charset="-122"/>
+                <a:cs typeface="Inter" pitchFamily="34" charset="-120"/>
+              </a:rPr>
+              <a:t>Worst star → template #1: the sub plan.
+</a:t>
+            </a:r>
+            <a:pPr indent="0" marL="0">
+              <a:lnSpc>
+                <a:spcPct val="120000"/>
+              </a:lnSpc>
+              <a:buNone/>
+            </a:pPr>
+            <a:r>
+              <a:rPr lang="en-US" sz="1900" dirty="0">
+                <a:solidFill>
+                  <a:srgbClr val="1B1F24"/>
+                </a:solidFill>
+                <a:latin typeface="Inter" pitchFamily="34" charset="0"/>
+                <a:ea typeface="Inter" pitchFamily="34" charset="-122"/>
+                <a:cs typeface="Inter" pitchFamily="34" charset="-120"/>
+              </a:rPr>
+              <a:t>Her template: slide 9's four-part prompt, with [GRADE], [TOPIC], and [ROUTINE] left as brackets.
+</a:t>
+            </a:r>
+            <a:pPr indent="0" marL="0">
+              <a:lnSpc>
+                <a:spcPct val="120000"/>
+              </a:lnSpc>
+              <a:buNone/>
+            </a:pPr>
+            <a:r>
+              <a:rPr lang="en-US" sz="1900" i="1" dirty="0">
+                <a:solidFill>
+                  <a:srgbClr val="5B6B7A"/>
+                </a:solidFill>
+                <a:latin typeface="Inter" pitchFamily="34" charset="0"/>
+                <a:ea typeface="Inter" pitchFamily="34" charset="-122"/>
+                <a:cs typeface="Inter" pitchFamily="34" charset="-120"/>
+              </a:rPr>
+              <a:t>Tested on a second real absence: works. Saved.</a:t>
+            </a:r>
+            <a:endParaRPr lang="en-US" sz="1900" dirty="0"/>
           </a:p>
         </p:txBody>
       </p:sp>
@@ -12115,7 +12475,7 @@
                 <a:ea typeface="Inter" pitchFamily="34" charset="-122"/>
                 <a:cs typeface="Inter" pitchFamily="34" charset="-120"/>
               </a:rPr>
-              <a:t>Her template #2: exit tickets from any objective; both saved to the staff doc.</a:t>
+              <a:t>Her week audit, step 3: star #2, exit tickets, is template #2; both go to the staff doc.</a:t>
             </a:r>
             <a:endParaRPr lang="en-US" sz="1000" dirty="0"/>
           </a:p>
@@ -12169,7 +12529,7 @@
         <p:spPr>
           <a:xfrm>
             <a:off x="548640" y="384048"/>
-            <a:ext cx="11091672" cy="777240"/>
+            <a:ext cx="7955280" cy="777240"/>
           </a:xfrm>
           <a:prstGeom prst="rect">
             <a:avLst/>
@@ -12207,8 +12567,8 @@
         </p:nvSpPr>
         <p:spPr>
           <a:xfrm>
-            <a:off x="640080" y="1371600"/>
-            <a:ext cx="10908792" cy="4297680"/>
+            <a:off x="640080" y="1554480"/>
+            <a:ext cx="5394960" cy="4023360"/>
           </a:xfrm>
           <a:prstGeom prst="rect">
             <a:avLst/>
@@ -12228,7 +12588,7 @@
               <a:buChar char="•"/>
             </a:pPr>
             <a:r>
-              <a:rPr lang="en-US" sz="2100" dirty="0">
+              <a:rPr lang="en-US" sz="1800" dirty="0">
                 <a:solidFill>
                   <a:srgbClr val="1B1F24"/>
                 </a:solidFill>
@@ -12238,7 +12598,7 @@
               </a:rPr>
               <a:t>Same recipe, second-worst repeater</a:t>
             </a:r>
-            <a:endParaRPr lang="en-US" sz="2100" dirty="0"/>
+            <a:endParaRPr lang="en-US" sz="1800" dirty="0"/>
           </a:p>
           <a:p>
             <a:pPr marL="342900" indent="-342900">
@@ -12249,7 +12609,7 @@
               <a:buChar char="•"/>
             </a:pPr>
             <a:r>
-              <a:rPr lang="en-US" sz="2100" dirty="0">
+              <a:rPr lang="en-US" sz="1800" dirty="0">
                 <a:solidFill>
                   <a:srgbClr val="1B1F24"/>
                 </a:solidFill>
@@ -12259,7 +12619,7 @@
               </a:rPr>
               <a:t>Both templates go to the staff doc's Workload section: name attached, one line each</a:t>
             </a:r>
-            <a:endParaRPr lang="en-US" sz="2100" dirty="0"/>
+            <a:endParaRPr lang="en-US" sz="1800" dirty="0"/>
           </a:p>
           <a:p>
             <a:pPr marL="342900" indent="-342900">
@@ -12270,7 +12630,7 @@
               <a:buChar char="•"/>
             </a:pPr>
             <a:r>
-              <a:rPr lang="en-US" sz="2100" b="1" dirty="0">
+              <a:rPr lang="en-US" sz="1800" b="1" dirty="0">
                 <a:solidFill>
                   <a:srgbClr val="1B1F24"/>
                 </a:solidFill>
@@ -12280,7 +12640,151 @@
               </a:rPr>
               <a:t>Sixty deleted repeaters, remember. Your Tuesday night is about to become everyone's.</a:t>
             </a:r>
-            <a:endParaRPr lang="en-US" sz="2100" dirty="0"/>
+            <a:endParaRPr lang="en-US" sz="1800" dirty="0"/>
+          </a:p>
+        </p:txBody>
+      </p:sp>
+      <p:sp>
+        <p:nvSpPr>
+          <p:cNvPr id="15" name="Shape 12"/>
+          <p:cNvSpPr/>
+          <p:nvPr/>
+        </p:nvSpPr>
+        <p:spPr>
+          <a:xfrm>
+            <a:off x="6263640" y="1554480"/>
+            <a:ext cx="5394960" cy="4023360"/>
+          </a:xfrm>
+          <a:prstGeom prst="roundRect">
+            <a:avLst>
+              <a:gd name="adj" fmla="val 2045"/>
+            </a:avLst>
+          </a:prstGeom>
+          <a:solidFill>
+            <a:srgbClr val="EAF5F3"/>
+          </a:solidFill>
+          <a:ln w="12700">
+            <a:solidFill>
+              <a:srgbClr val="EAF5F3"/>
+            </a:solidFill>
+            <a:prstDash val="solid"/>
+          </a:ln>
+        </p:spPr>
+      </p:sp>
+      <p:sp>
+        <p:nvSpPr>
+          <p:cNvPr id="16" name="Text 13"/>
+          <p:cNvSpPr/>
+          <p:nvPr/>
+        </p:nvSpPr>
+        <p:spPr>
+          <a:xfrm>
+            <a:off x="6537960" y="1737360"/>
+            <a:ext cx="4937760" cy="292608"/>
+          </a:xfrm>
+          <a:prstGeom prst="rect">
+            <a:avLst/>
+          </a:prstGeom>
+          <a:noFill/>
+          <a:ln/>
+        </p:spPr>
+        <p:txBody>
+          <a:bodyPr wrap="square" lIns="0" tIns="0" rIns="0" bIns="0" rtlCol="0" anchor="ctr"/>
+          <a:lstStyle/>
+          <a:p>
+            <a:pPr indent="0" marL="0">
+              <a:buNone/>
+            </a:pPr>
+            <a:r>
+              <a:rPr lang="en-US" sz="1250" b="1" spc="150" kern="0" dirty="0">
+                <a:solidFill>
+                  <a:srgbClr val="2A9D8F"/>
+                </a:solidFill>
+                <a:latin typeface="Inter" pitchFamily="34" charset="0"/>
+                <a:ea typeface="Inter" pitchFamily="34" charset="-122"/>
+                <a:cs typeface="Inter" pitchFamily="34" charset="-120"/>
+              </a:rPr>
+              <a:t>MS. RIVERA'S WEEK AUDIT · STEP 3</a:t>
+            </a:r>
+            <a:endParaRPr lang="en-US" sz="1250" dirty="0"/>
+          </a:p>
+        </p:txBody>
+      </p:sp>
+      <p:sp>
+        <p:nvSpPr>
+          <p:cNvPr id="17" name="Text 14"/>
+          <p:cNvSpPr/>
+          <p:nvPr/>
+        </p:nvSpPr>
+        <p:spPr>
+          <a:xfrm>
+            <a:off x="6537960" y="2148840"/>
+            <a:ext cx="4892040" cy="3291840"/>
+          </a:xfrm>
+          <a:prstGeom prst="rect">
+            <a:avLst/>
+          </a:prstGeom>
+          <a:noFill/>
+          <a:ln/>
+        </p:spPr>
+        <p:txBody>
+          <a:bodyPr wrap="square" lIns="0" tIns="0" rIns="0" bIns="0" rtlCol="0" anchor="t"/>
+          <a:lstStyle/>
+          <a:p>
+            <a:pPr indent="0" marL="0">
+              <a:lnSpc>
+                <a:spcPct val="120000"/>
+              </a:lnSpc>
+              <a:buNone/>
+            </a:pPr>
+            <a:r>
+              <a:rPr lang="en-US" sz="1900" b="1" dirty="0">
+                <a:solidFill>
+                  <a:srgbClr val="13293D"/>
+                </a:solidFill>
+                <a:latin typeface="Inter" pitchFamily="34" charset="0"/>
+                <a:ea typeface="Inter" pitchFamily="34" charset="-122"/>
+                <a:cs typeface="Inter" pitchFamily="34" charset="-120"/>
+              </a:rPr>
+              <a:t>Star #2 → template #2: exit tickets.
+</a:t>
+            </a:r>
+            <a:pPr indent="0" marL="0">
+              <a:lnSpc>
+                <a:spcPct val="120000"/>
+              </a:lnSpc>
+              <a:buNone/>
+            </a:pPr>
+            <a:r>
+              <a:rPr lang="en-US" sz="1900" dirty="0">
+                <a:solidFill>
+                  <a:srgbClr val="1B1F24"/>
+                </a:solidFill>
+                <a:latin typeface="Inter" pitchFamily="34" charset="0"/>
+                <a:ea typeface="Inter" pitchFamily="34" charset="-122"/>
+                <a:cs typeface="Inter" pitchFamily="34" charset="-120"/>
+              </a:rPr>
+              <a:t>"Write five exit-ticket questions for [OBJECTIVE], mixed recall and reasoning, answer key last."
+</a:t>
+            </a:r>
+            <a:pPr indent="0" marL="0">
+              <a:lnSpc>
+                <a:spcPct val="120000"/>
+              </a:lnSpc>
+              <a:buNone/>
+            </a:pPr>
+            <a:r>
+              <a:rPr lang="en-US" sz="1900" i="1" dirty="0">
+                <a:solidFill>
+                  <a:srgbClr val="5B6B7A"/>
+                </a:solidFill>
+                <a:latin typeface="Inter" pitchFamily="34" charset="0"/>
+                <a:ea typeface="Inter" pitchFamily="34" charset="-122"/>
+                <a:cs typeface="Inter" pitchFamily="34" charset="-120"/>
+              </a:rPr>
+              <a:t>Both templates posted to the staff doc, name attached.</a:t>
+            </a:r>
+            <a:endParaRPr lang="en-US" sz="1900" dirty="0"/>
           </a:p>
         </p:txBody>
       </p:sp>
@@ -12633,7 +13137,7 @@
                 <a:ea typeface="Inter" pitchFamily="34" charset="-122"/>
                 <a:cs typeface="Inter" pitchFamily="34" charset="-120"/>
               </a:rPr>
-              <a:t>Her protected list, written: the work that stays hers on purpose.</a:t>
+              <a:t>Her week audit, step 4: the unstarred column becomes her protected list, in ink.</a:t>
             </a:r>
             <a:endParaRPr lang="en-US" sz="1000" dirty="0"/>
           </a:p>
@@ -12687,7 +13191,7 @@
         <p:spPr>
           <a:xfrm>
             <a:off x="548640" y="384048"/>
-            <a:ext cx="11091672" cy="777240"/>
+            <a:ext cx="7955280" cy="777240"/>
           </a:xfrm>
           <a:prstGeom prst="rect">
             <a:avLst/>
@@ -12726,11 +13230,11 @@
         <p:spPr>
           <a:xfrm>
             <a:off x="640080" y="1554480"/>
-            <a:ext cx="10972800" cy="2377440"/>
+            <a:ext cx="5394960" cy="2651760"/>
           </a:xfrm>
           <a:prstGeom prst="roundRect">
             <a:avLst>
-              <a:gd name="adj" fmla="val 3462"/>
+              <a:gd name="adj" fmla="val 3103"/>
             </a:avLst>
           </a:prstGeom>
           <a:solidFill>
@@ -12752,17 +13256,125 @@
         </p:nvSpPr>
         <p:spPr>
           <a:xfrm>
-            <a:off x="960120" y="1828800"/>
-            <a:ext cx="10332720" cy="1828800"/>
-          </a:xfrm>
-          <a:prstGeom prst="rect">
-            <a:avLst/>
-          </a:prstGeom>
-          <a:noFill/>
-          <a:ln/>
-        </p:spPr>
-        <p:txBody>
-          <a:bodyPr wrap="square" lIns="0" tIns="0" rIns="0" bIns="0" rtlCol="0" anchor="ctr"/>
+            <a:off x="914400" y="1783080"/>
+            <a:ext cx="4846320" cy="2194560"/>
+          </a:xfrm>
+          <a:prstGeom prst="rect">
+            <a:avLst/>
+          </a:prstGeom>
+          <a:noFill/>
+          <a:ln/>
+        </p:spPr>
+        <p:txBody>
+          <a:bodyPr wrap="square" lIns="0" tIns="0" rIns="0" bIns="0" rtlCol="0" anchor="ctr"/>
+          <a:lstStyle/>
+          <a:p>
+            <a:pPr indent="0" marL="0">
+              <a:lnSpc>
+                <a:spcPct val="125000"/>
+              </a:lnSpc>
+              <a:buNone/>
+            </a:pPr>
+            <a:r>
+              <a:rPr lang="en-US" sz="1900" dirty="0">
+                <a:solidFill>
+                  <a:srgbClr val="1B1F24"/>
+                </a:solidFill>
+                <a:latin typeface="Inter" pitchFamily="34" charset="0"/>
+                <a:ea typeface="Inter" pitchFamily="34" charset="-122"/>
+                <a:cs typeface="Inter" pitchFamily="34" charset="-120"/>
+              </a:rPr>
+              <a:t>Three to five pieces of this job you are keeping, by decision, no matter how good the tools get.</a:t>
+            </a:r>
+            <a:endParaRPr lang="en-US" sz="1900" dirty="0"/>
+          </a:p>
+        </p:txBody>
+      </p:sp>
+      <p:sp>
+        <p:nvSpPr>
+          <p:cNvPr id="16" name="Shape 13"/>
+          <p:cNvSpPr/>
+          <p:nvPr/>
+        </p:nvSpPr>
+        <p:spPr>
+          <a:xfrm>
+            <a:off x="6263640" y="1554480"/>
+            <a:ext cx="5394960" cy="2651760"/>
+          </a:xfrm>
+          <a:prstGeom prst="roundRect">
+            <a:avLst>
+              <a:gd name="adj" fmla="val 3103"/>
+            </a:avLst>
+          </a:prstGeom>
+          <a:solidFill>
+            <a:srgbClr val="EAF5F3"/>
+          </a:solidFill>
+          <a:ln w="12700">
+            <a:solidFill>
+              <a:srgbClr val="EAF5F3"/>
+            </a:solidFill>
+            <a:prstDash val="solid"/>
+          </a:ln>
+        </p:spPr>
+      </p:sp>
+      <p:sp>
+        <p:nvSpPr>
+          <p:cNvPr id="17" name="Text 14"/>
+          <p:cNvSpPr/>
+          <p:nvPr/>
+        </p:nvSpPr>
+        <p:spPr>
+          <a:xfrm>
+            <a:off x="6537960" y="1737360"/>
+            <a:ext cx="4937760" cy="292608"/>
+          </a:xfrm>
+          <a:prstGeom prst="rect">
+            <a:avLst/>
+          </a:prstGeom>
+          <a:noFill/>
+          <a:ln/>
+        </p:spPr>
+        <p:txBody>
+          <a:bodyPr wrap="square" lIns="0" tIns="0" rIns="0" bIns="0" rtlCol="0" anchor="ctr"/>
+          <a:lstStyle/>
+          <a:p>
+            <a:pPr indent="0" marL="0">
+              <a:buNone/>
+            </a:pPr>
+            <a:r>
+              <a:rPr lang="en-US" sz="1250" b="1" spc="150" kern="0" dirty="0">
+                <a:solidFill>
+                  <a:srgbClr val="2A9D8F"/>
+                </a:solidFill>
+                <a:latin typeface="Inter" pitchFamily="34" charset="0"/>
+                <a:ea typeface="Inter" pitchFamily="34" charset="-122"/>
+                <a:cs typeface="Inter" pitchFamily="34" charset="-120"/>
+              </a:rPr>
+              <a:t>MS. RIVERA'S WEEK AUDIT · STEP 4</a:t>
+            </a:r>
+            <a:endParaRPr lang="en-US" sz="1250" dirty="0"/>
+          </a:p>
+        </p:txBody>
+      </p:sp>
+      <p:sp>
+        <p:nvSpPr>
+          <p:cNvPr id="18" name="Text 15"/>
+          <p:cNvSpPr/>
+          <p:nvPr/>
+        </p:nvSpPr>
+        <p:spPr>
+          <a:xfrm>
+            <a:off x="6537960" y="2148840"/>
+            <a:ext cx="4892040" cy="1920240"/>
+          </a:xfrm>
+          <a:prstGeom prst="rect">
+            <a:avLst/>
+          </a:prstGeom>
+          <a:noFill/>
+          <a:ln/>
+        </p:spPr>
+        <p:txBody>
+          <a:bodyPr wrap="square" lIns="0" tIns="0" rIns="0" bIns="0" rtlCol="0" anchor="t"/>
           <a:lstStyle/>
           <a:p>
             <a:pPr indent="0" marL="0">
@@ -12772,29 +13384,49 @@
               <a:buNone/>
             </a:pPr>
             <a:r>
-              <a:rPr lang="en-US" sz="2400" dirty="0">
-                <a:solidFill>
-                  <a:srgbClr val="1B1F24"/>
-                </a:solidFill>
-                <a:latin typeface="Inter" pitchFamily="34" charset="0"/>
-                <a:ea typeface="Inter" pitchFamily="34" charset="-122"/>
-                <a:cs typeface="Inter" pitchFamily="34" charset="-120"/>
-              </a:rPr>
-              <a:t>Three to five pieces of this job you are keeping, by decision, no matter how good the tools get.</a:t>
-            </a:r>
-            <a:endParaRPr lang="en-US" sz="2400" dirty="0"/>
-          </a:p>
-        </p:txBody>
-      </p:sp>
-      <p:sp>
-        <p:nvSpPr>
-          <p:cNvPr id="16" name="Text 13"/>
-          <p:cNvSpPr/>
-          <p:nvPr/>
-        </p:nvSpPr>
-        <p:spPr>
-          <a:xfrm>
-            <a:off x="640080" y="4297680"/>
+              <a:rPr lang="en-US" sz="2000" b="1" dirty="0">
+                <a:solidFill>
+                  <a:srgbClr val="13293D"/>
+                </a:solidFill>
+                <a:latin typeface="Inter" pitchFamily="34" charset="0"/>
+                <a:ea typeface="Inter" pitchFamily="34" charset="-122"/>
+                <a:cs typeface="Inter" pitchFamily="34" charset="-120"/>
+              </a:rPr>
+              <a:t>Feedback conversations.
+Grading judgment.
+Greeting kids at the door.
+</a:t>
+            </a:r>
+            <a:pPr indent="0" marL="0">
+              <a:lnSpc>
+                <a:spcPct val="120000"/>
+              </a:lnSpc>
+              <a:buNone/>
+            </a:pPr>
+            <a:r>
+              <a:rPr lang="en-US" sz="1600" i="1" dirty="0">
+                <a:solidFill>
+                  <a:srgbClr val="5B6B7A"/>
+                </a:solidFill>
+                <a:latin typeface="Inter" pitchFamily="34" charset="0"/>
+                <a:ea typeface="Inter" pitchFamily="34" charset="-122"/>
+                <a:cs typeface="Inter" pitchFamily="34" charset="-120"/>
+              </a:rPr>
+              <a:t>Her protected list: the unstarred column of her audit, kept on purpose.</a:t>
+            </a:r>
+            <a:endParaRPr lang="en-US" sz="2000" dirty="0"/>
+          </a:p>
+        </p:txBody>
+      </p:sp>
+      <p:sp>
+        <p:nvSpPr>
+          <p:cNvPr id="19" name="Text 16"/>
+          <p:cNvSpPr/>
+          <p:nvPr/>
+        </p:nvSpPr>
+        <p:spPr>
+          <a:xfrm>
+            <a:off x="640080" y="4526280"/>
             <a:ext cx="10972800" cy="548640"/>
           </a:xfrm>
           <a:prstGeom prst="rect">
@@ -13174,7 +13806,7 @@
                 <a:ea typeface="Inter" pitchFamily="34" charset="-122"/>
                 <a:cs typeface="Inter" pitchFamily="34" charset="-120"/>
               </a:rPr>
-              <a:t>Her share-out: the task she's taking back, and the hour it frees.</a:t>
+              <a:t>Her share-out, from the same audit: the sub plan star, and the evenings it frees.</a:t>
             </a:r>
             <a:endParaRPr lang="en-US" sz="1000" dirty="0"/>
           </a:p>

</xml_diff>